<commit_message>
Capturas del agente, informe en PDF y presentación
</commit_message>
<xml_diff>
--- a/reports/Presentacion_pronostico_costos_equipos.pptx
+++ b/reports/Presentacion_pronostico_costos_equipos.pptx
@@ -17,9 +17,10 @@
     <p:sldId id="265" r:id="rId11"/>
     <p:sldId id="266" r:id="rId12"/>
     <p:sldId id="267" r:id="rId13"/>
+    <p:sldId id="268" r:id="rId14"/>
   </p:sldIdLst>
   <p:notesMasterIdLst>
-    <p:notesMasterId r:id="rId14"/>
+    <p:notesMasterId r:id="rId15"/>
   </p:notesMasterIdLst>
   <p:sldSz cx="12192000" cy="6858000"/>
   <p:notesSz cx="6858000" cy="12192000"/>
@@ -1549,6 +1550,94 @@
             <a:fld id="{F7021451-1387-4CA6-816F-3879F97B5CBC}" type="slidenum">
               <a:rPr lang="en-US"/>
               <a:t>12</a:t>
+            </a:fld>
+            <a:endParaRPr lang="en-US"/>
+          </a:p>
+        </p:txBody>
+      </p:sp>
+    </p:spTree>
+    <p:extLst>
+      <p:ext uri="{BB962C8B-B14F-4D97-AF65-F5344CB8AC3E}">
+        <p14:creationId xmlns:p14="http://schemas.microsoft.com/office/powerpoint/2010/main" val="1024086991"/>
+      </p:ext>
+    </p:extLst>
+  </p:cSld>
+  <p:clrMapOvr>
+    <a:masterClrMapping/>
+  </p:clrMapOvr>
+</p:notes>
+</file>
+
+<file path=ppt/notesSlides/notesSlide13.xml><?xml version="1.0" encoding="utf-8"?>
+<p:notes xmlns:a="http://schemas.openxmlformats.org/drawingml/2006/main" xmlns:r="http://schemas.openxmlformats.org/officeDocument/2006/relationships" xmlns:p="http://schemas.openxmlformats.org/presentationml/2006/main">
+  <p:cSld>
+    <p:spTree>
+      <p:nvGrpSpPr>
+        <p:cNvPr id="1" name=""/>
+        <p:cNvGrpSpPr/>
+        <p:nvPr/>
+      </p:nvGrpSpPr>
+      <p:grpSpPr>
+        <a:xfrm>
+          <a:off x="0" y="0"/>
+          <a:ext cx="0" cy="0"/>
+          <a:chOff x="0" y="0"/>
+          <a:chExt cx="0" cy="0"/>
+        </a:xfrm>
+      </p:grpSpPr>
+      <p:sp>
+        <p:nvSpPr>
+          <p:cNvPr id="2" name="Slide Image Placeholder 1"/>
+          <p:cNvSpPr>
+            <a:spLocks noGrp="1" noRot="1" noChangeAspect="1"/>
+          </p:cNvSpPr>
+          <p:nvPr>
+            <p:ph type="sldImg"/>
+          </p:nvPr>
+        </p:nvSpPr>
+        <p:spPr/>
+      </p:sp>
+      <p:sp>
+        <p:nvSpPr>
+          <p:cNvPr id="3" name="Notes Placeholder 2"/>
+          <p:cNvSpPr>
+            <a:spLocks noGrp="1"/>
+          </p:cNvSpPr>
+          <p:nvPr>
+            <p:ph type="body" idx="1"/>
+          </p:nvPr>
+        </p:nvSpPr>
+        <p:spPr/>
+        <p:txBody>
+          <a:bodyPr/>
+          <a:lstStyle/>
+          <a:p>
+            <a:r>
+              <a:rPr lang="en-US" dirty="0"/>
+              <a:t/>
+            </a:r>
+            <a:endParaRPr lang="en-US" dirty="0"/>
+          </a:p>
+        </p:txBody>
+      </p:sp>
+      <p:sp>
+        <p:nvSpPr>
+          <p:cNvPr id="4" name="Slide Number Placeholder 3"/>
+          <p:cNvSpPr>
+            <a:spLocks noGrp="1"/>
+          </p:cNvSpPr>
+          <p:nvPr>
+            <p:ph type="sldNum" sz="quarter" idx="10"/>
+          </p:nvPr>
+        </p:nvSpPr>
+        <p:spPr/>
+        <p:txBody>
+          <a:bodyPr/>
+          <a:lstStyle/>
+          <a:p>
+            <a:fld id="{F7021451-1387-4CA6-816F-3879F97B5CBC}" type="slidenum">
+              <a:rPr lang="en-US"/>
+              <a:t>13</a:t>
             </a:fld>
             <a:endParaRPr lang="en-US"/>
           </a:p>
@@ -2903,7 +2992,7 @@
                 <a:ea typeface="Cambria" pitchFamily="34" charset="-122"/>
                 <a:cs typeface="Cambria" pitchFamily="34" charset="-120"/>
               </a:rPr>
-              <a:t>Lo implementado</a:t>
+              <a:t>El agente en uso</a:t>
             </a:r>
             <a:endParaRPr lang="en-US" sz="3000" dirty="0"/>
           </a:p>
@@ -2942,7 +3031,7 @@
                 <a:ea typeface="Calibri" pitchFamily="34" charset="-122"/>
                 <a:cs typeface="Calibri" pitchFamily="34" charset="-120"/>
               </a:rPr>
-              <a:t>Un pipeline de etapas independientes, cada una dejando artefactos que la siguiente consume</a:t>
+              <a:t>Una cotización de proveedor contrastada contra el rango proyectado</a:t>
             </a:r>
             <a:endParaRPr lang="en-US" sz="1400" dirty="0"/>
           </a:p>
@@ -2950,7 +3039,7 @@
       </p:sp>
       <p:pic>
         <p:nvPicPr>
-          <p:cNvPr id="4" name="Image 0" descr="docs/arquitectura_local.png">    </p:cNvPr>
+          <p:cNvPr id="4" name="Image 0" descr="figures/agente_cotizacion_recorte.png">    </p:cNvPr>
           <p:cNvPicPr>
             <a:picLocks noChangeAspect="1"/>
           </p:cNvPicPr>
@@ -2964,8 +3053,8 @@
         </p:blipFill>
         <p:spPr>
           <a:xfrm>
-            <a:off x="3977640" y="1600200"/>
-            <a:ext cx="4206240" cy="4572000"/>
+            <a:off x="640080" y="1737360"/>
+            <a:ext cx="7498080" cy="4407408"/>
           </a:xfrm>
           <a:prstGeom prst="rect">
             <a:avLst/>
@@ -2980,24 +3069,24 @@
         </p:nvSpPr>
         <p:spPr>
           <a:xfrm>
-            <a:off x="640080" y="1828800"/>
-            <a:ext cx="3108960" cy="320040"/>
-          </a:xfrm>
-          <a:prstGeom prst="rect">
-            <a:avLst/>
-          </a:prstGeom>
-          <a:noFill/>
-          <a:ln/>
-        </p:spPr>
-        <p:txBody>
-          <a:bodyPr wrap="square" lIns="0" tIns="0" rIns="0" bIns="0" rtlCol="0" anchor="ctr"/>
-          <a:lstStyle/>
-          <a:p>
-            <a:pPr indent="0" marL="0">
-              <a:buNone/>
-            </a:pPr>
-            <a:r>
-              <a:rPr lang="en-US" sz="1400" b="1" dirty="0">
+            <a:off x="8458200" y="1828800"/>
+            <a:ext cx="3063240" cy="320040"/>
+          </a:xfrm>
+          <a:prstGeom prst="rect">
+            <a:avLst/>
+          </a:prstGeom>
+          <a:noFill/>
+          <a:ln/>
+        </p:spPr>
+        <p:txBody>
+          <a:bodyPr wrap="square" lIns="0" tIns="0" rIns="0" bIns="0" rtlCol="0" anchor="ctr"/>
+          <a:lstStyle/>
+          <a:p>
+            <a:pPr indent="0" marL="0">
+              <a:buNone/>
+            </a:pPr>
+            <a:r>
+              <a:rPr lang="en-US" sz="1500" b="1" dirty="0">
                 <a:solidFill>
                   <a:srgbClr val="B85042"/>
                 </a:solidFill>
@@ -3005,9 +3094,9 @@
                 <a:ea typeface="Cambria" pitchFamily="34" charset="-122"/>
                 <a:cs typeface="Cambria" pitchFamily="34" charset="-120"/>
               </a:rPr>
-              <a:t>Reproducible en un comando</a:t>
-            </a:r>
-            <a:endParaRPr lang="en-US" sz="1400" dirty="0"/>
+              <a:t>Qué hace aquí</a:t>
+            </a:r>
+            <a:endParaRPr lang="en-US" sz="1500" dirty="0"/>
           </a:p>
         </p:txBody>
       </p:sp>
@@ -3019,8 +3108,8 @@
         </p:nvSpPr>
         <p:spPr>
           <a:xfrm>
-            <a:off x="640080" y="2194560"/>
-            <a:ext cx="3108960" cy="1097280"/>
+            <a:off x="8458200" y="2212848"/>
+            <a:ext cx="3063240" cy="1188720"/>
           </a:xfrm>
           <a:prstGeom prst="rect">
             <a:avLst/>
@@ -3047,7 +3136,7 @@
                 <a:ea typeface="Calibri" pitchFamily="34" charset="-122"/>
                 <a:cs typeface="Calibri" pitchFamily="34" charset="-120"/>
               </a:rPr>
-              <a:t>make all encadena ingesta, selección de modelo y pronóstico. Cada etapa corre también por separado con uv run.</a:t>
+              <a:t>Lee el precio ofertado, lo compara con el intervalo del mes correspondiente y concluye que supera incluso el percentil 95.</a:t>
             </a:r>
             <a:endParaRPr lang="en-US" sz="1200" dirty="0"/>
           </a:p>
@@ -3061,24 +3150,24 @@
         </p:nvSpPr>
         <p:spPr>
           <a:xfrm>
-            <a:off x="640080" y="3429000"/>
-            <a:ext cx="3108960" cy="320040"/>
-          </a:xfrm>
-          <a:prstGeom prst="rect">
-            <a:avLst/>
-          </a:prstGeom>
-          <a:noFill/>
-          <a:ln/>
-        </p:spPr>
-        <p:txBody>
-          <a:bodyPr wrap="square" lIns="0" tIns="0" rIns="0" bIns="0" rtlCol="0" anchor="ctr"/>
-          <a:lstStyle/>
-          <a:p>
-            <a:pPr indent="0" marL="0">
-              <a:buNone/>
-            </a:pPr>
-            <a:r>
-              <a:rPr lang="en-US" sz="1400" b="1" dirty="0">
+            <a:off x="8458200" y="3566160"/>
+            <a:ext cx="3063240" cy="320040"/>
+          </a:xfrm>
+          <a:prstGeom prst="rect">
+            <a:avLst/>
+          </a:prstGeom>
+          <a:noFill/>
+          <a:ln/>
+        </p:spPr>
+        <p:txBody>
+          <a:bodyPr wrap="square" lIns="0" tIns="0" rIns="0" bIns="0" rtlCol="0" anchor="ctr"/>
+          <a:lstStyle/>
+          <a:p>
+            <a:pPr indent="0" marL="0">
+              <a:buNone/>
+            </a:pPr>
+            <a:r>
+              <a:rPr lang="en-US" sz="1500" b="1" dirty="0">
                 <a:solidFill>
                   <a:srgbClr val="B85042"/>
                 </a:solidFill>
@@ -3086,9 +3175,9 @@
                 <a:ea typeface="Cambria" pitchFamily="34" charset="-122"/>
                 <a:cs typeface="Cambria" pitchFamily="34" charset="-120"/>
               </a:rPr>
-              <a:t>Artefactos versionados</a:t>
-            </a:r>
-            <a:endParaRPr lang="en-US" sz="1400" dirty="0"/>
+              <a:t>Por qué importa</a:t>
+            </a:r>
+            <a:endParaRPr lang="en-US" sz="1500" dirty="0"/>
           </a:p>
         </p:txBody>
       </p:sp>
@@ -3100,8 +3189,8 @@
         </p:nvSpPr>
         <p:spPr>
           <a:xfrm>
-            <a:off x="640080" y="3794760"/>
-            <a:ext cx="3108960" cy="1280160"/>
+            <a:off x="8458200" y="3950208"/>
+            <a:ext cx="3063240" cy="1188720"/>
           </a:xfrm>
           <a:prstGeom prst="rect">
             <a:avLst/>
@@ -3128,7 +3217,7 @@
                 <a:ea typeface="Calibri" pitchFamily="34" charset="-122"/>
                 <a:cs typeface="Calibri" pitchFamily="34" charset="-120"/>
               </a:rPr>
-              <a:t>El histórico procesado, la selección de modelo y los pronósticos quedan en el repositorio, de modo que el resultado es auditable sin reejecutar nada.</a:t>
+              <a:t>No se queda en el veredicto: señala el margen de renegociación y qué condiciones comerciales justificarían el sobreprecio.</a:t>
             </a:r>
             <a:endParaRPr lang="en-US" sz="1200" dirty="0"/>
           </a:p>
@@ -3136,42 +3225,30 @@
       </p:sp>
       <p:sp>
         <p:nvSpPr>
-          <p:cNvPr id="9" name="Text 6"/>
-          <p:cNvSpPr txBox="1"/>
-          <p:nvPr/>
-        </p:nvSpPr>
-        <p:spPr>
-          <a:xfrm>
-            <a:off x="8412480" y="1828800"/>
-            <a:ext cx="3108960" cy="320040"/>
-          </a:xfrm>
-          <a:prstGeom prst="rect">
-            <a:avLst/>
-          </a:prstGeom>
-          <a:noFill/>
-          <a:ln/>
-        </p:spPr>
-        <p:txBody>
-          <a:bodyPr wrap="square" lIns="0" tIns="0" rIns="0" bIns="0" rtlCol="0" anchor="ctr"/>
-          <a:lstStyle/>
-          <a:p>
-            <a:pPr indent="0" marL="0">
-              <a:buNone/>
-            </a:pPr>
-            <a:r>
-              <a:rPr lang="en-US" sz="1400" b="1" dirty="0">
-                <a:solidFill>
-                  <a:srgbClr val="B85042"/>
-                </a:solidFill>
-                <a:latin typeface="Cambria" pitchFamily="34" charset="0"/>
-                <a:ea typeface="Cambria" pitchFamily="34" charset="-122"/>
-                <a:cs typeface="Cambria" pitchFamily="34" charset="-120"/>
-              </a:rPr>
-              <a:t>El agente</a:t>
-            </a:r>
-            <a:endParaRPr lang="en-US" sz="1400" dirty="0"/>
-          </a:p>
-        </p:txBody>
+          <p:cNvPr id="9" name="Shape 6"/>
+          <p:cNvSpPr/>
+          <p:nvPr/>
+        </p:nvSpPr>
+        <p:spPr>
+          <a:xfrm>
+            <a:off x="8458200" y="5212080"/>
+            <a:ext cx="3063240" cy="1005840"/>
+          </a:xfrm>
+          <a:prstGeom prst="roundRect">
+            <a:avLst>
+              <a:gd name="adj" fmla="val 7273"/>
+            </a:avLst>
+          </a:prstGeom>
+          <a:solidFill>
+            <a:srgbClr val="F5EFEA"/>
+          </a:solidFill>
+          <a:ln w="12700">
+            <a:solidFill>
+              <a:srgbClr val="B85042"/>
+            </a:solidFill>
+            <a:prstDash val="solid"/>
+          </a:ln>
+        </p:spPr>
       </p:sp>
       <p:sp>
         <p:nvSpPr>
@@ -3181,8 +3258,8 @@
         </p:nvSpPr>
         <p:spPr>
           <a:xfrm>
-            <a:off x="8412480" y="2194560"/>
-            <a:ext cx="3108960" cy="1280160"/>
+            <a:off x="8686800" y="5376672"/>
+            <a:ext cx="2651760" cy="731520"/>
           </a:xfrm>
           <a:prstGeom prst="rect">
             <a:avLst/>
@@ -3196,103 +3273,22 @@
           <a:p>
             <a:pPr indent="0" marL="0">
               <a:lnSpc>
-                <a:spcPts val="1700"/>
+                <a:spcPts val="1600"/>
               </a:lnSpc>
               <a:buNone/>
             </a:pPr>
             <a:r>
-              <a:rPr lang="en-US" sz="1200" dirty="0">
-                <a:solidFill>
-                  <a:srgbClr val="6B6A64"/>
+              <a:rPr lang="en-US" sz="1150" dirty="0">
+                <a:solidFill>
+                  <a:srgbClr val="2B2B28"/>
                 </a:solidFill>
                 <a:latin typeface="Calibri" pitchFamily="34" charset="0"/>
                 <a:ea typeface="Calibri" pitchFamily="34" charset="-122"/>
                 <a:cs typeface="Calibri" pitchFamily="34" charset="-120"/>
               </a:rPr>
-              <a:t>El grafo decide si consulta la rama interna, que lee los artefactos, o la externa, que busca en la web, y mantiene el estado de la conversación.</a:t>
-            </a:r>
-            <a:endParaRPr lang="en-US" sz="1200" dirty="0"/>
-          </a:p>
-        </p:txBody>
-      </p:sp>
-      <p:sp>
-        <p:nvSpPr>
-          <p:cNvPr id="11" name="Text 8"/>
-          <p:cNvSpPr txBox="1"/>
-          <p:nvPr/>
-        </p:nvSpPr>
-        <p:spPr>
-          <a:xfrm>
-            <a:off x="8412480" y="3611880"/>
-            <a:ext cx="3108960" cy="320040"/>
-          </a:xfrm>
-          <a:prstGeom prst="rect">
-            <a:avLst/>
-          </a:prstGeom>
-          <a:noFill/>
-          <a:ln/>
-        </p:spPr>
-        <p:txBody>
-          <a:bodyPr wrap="square" lIns="0" tIns="0" rIns="0" bIns="0" rtlCol="0" anchor="ctr"/>
-          <a:lstStyle/>
-          <a:p>
-            <a:pPr indent="0" marL="0">
-              <a:buNone/>
-            </a:pPr>
-            <a:r>
-              <a:rPr lang="en-US" sz="1400" b="1" dirty="0">
-                <a:solidFill>
-                  <a:srgbClr val="B85042"/>
-                </a:solidFill>
-                <a:latin typeface="Cambria" pitchFamily="34" charset="0"/>
-                <a:ea typeface="Cambria" pitchFamily="34" charset="-122"/>
-                <a:cs typeface="Cambria" pitchFamily="34" charset="-120"/>
-              </a:rPr>
-              <a:t>Empaquetado</a:t>
-            </a:r>
-            <a:endParaRPr lang="en-US" sz="1400" dirty="0"/>
-          </a:p>
-        </p:txBody>
-      </p:sp>
-      <p:sp>
-        <p:nvSpPr>
-          <p:cNvPr id="12" name="Text 9"/>
-          <p:cNvSpPr txBox="1"/>
-          <p:nvPr/>
-        </p:nvSpPr>
-        <p:spPr>
-          <a:xfrm>
-            <a:off x="8412480" y="3977640"/>
-            <a:ext cx="3108960" cy="1097280"/>
-          </a:xfrm>
-          <a:prstGeom prst="rect">
-            <a:avLst/>
-          </a:prstGeom>
-          <a:noFill/>
-          <a:ln/>
-        </p:spPr>
-        <p:txBody>
-          <a:bodyPr wrap="square" lIns="0" tIns="0" rIns="0" bIns="0" rtlCol="0" anchor="ctr"/>
-          <a:lstStyle/>
-          <a:p>
-            <a:pPr indent="0" marL="0">
-              <a:lnSpc>
-                <a:spcPts val="1700"/>
-              </a:lnSpc>
-              <a:buNone/>
-            </a:pPr>
-            <a:r>
-              <a:rPr lang="en-US" sz="1200" dirty="0">
-                <a:solidFill>
-                  <a:srgbClr val="6B6A64"/>
-                </a:solidFill>
-                <a:latin typeface="Calibri" pitchFamily="34" charset="0"/>
-                <a:ea typeface="Calibri" pitchFamily="34" charset="-122"/>
-                <a:cs typeface="Calibri" pitchFamily="34" charset="-120"/>
-              </a:rPr>
-              <a:t>Un Dockerfile resuelve las dependencias de sistema y levanta el agente sin instalar nada en la máquina del usuario.</a:t>
-            </a:r>
-            <a:endParaRPr lang="en-US" sz="1200" dirty="0"/>
+              <a:t>Ninguna herramienta responde esta pregunta por sí sola. El agente arma la secuencia.</a:t>
+            </a:r>
+            <a:endParaRPr lang="en-US" sz="1150" dirty="0"/>
           </a:p>
         </p:txBody>
       </p:sp>
@@ -3361,7 +3357,7 @@
                 <a:ea typeface="Cambria" pitchFamily="34" charset="-122"/>
                 <a:cs typeface="Cambria" pitchFamily="34" charset="-120"/>
               </a:rPr>
-              <a:t>Cómo escalaría en Azure</a:t>
+              <a:t>Lo implementado</a:t>
             </a:r>
             <a:endParaRPr lang="en-US" sz="3000" dirty="0"/>
           </a:p>
@@ -3400,7 +3396,7 @@
                 <a:ea typeface="Calibri" pitchFamily="34" charset="-122"/>
                 <a:cs typeface="Calibri" pitchFamily="34" charset="-120"/>
               </a:rPr>
-              <a:t>La misma imagen que corre en local es la que se despliega, con dos configuraciones según el volumen</a:t>
+              <a:t>Un pipeline de etapas independientes, cada una dejando artefactos que la siguiente consume</a:t>
             </a:r>
             <a:endParaRPr lang="en-US" sz="1400" dirty="0"/>
           </a:p>
@@ -3408,7 +3404,7 @@
       </p:sp>
       <p:pic>
         <p:nvPicPr>
-          <p:cNvPr id="4" name="Image 0" descr="docs/arquitectura_azure.png">    </p:cNvPr>
+          <p:cNvPr id="4" name="Image 0" descr="docs/arquitectura_local.png">    </p:cNvPr>
           <p:cNvPicPr>
             <a:picLocks noChangeAspect="1"/>
           </p:cNvPicPr>
@@ -3422,8 +3418,8 @@
         </p:blipFill>
         <p:spPr>
           <a:xfrm>
-            <a:off x="3566160" y="1600200"/>
-            <a:ext cx="5029200" cy="4892040"/>
+            <a:off x="3977640" y="1600200"/>
+            <a:ext cx="4206240" cy="4572000"/>
           </a:xfrm>
           <a:prstGeom prst="rect">
             <a:avLst/>
@@ -3439,7 +3435,7 @@
         <p:spPr>
           <a:xfrm>
             <a:off x="640080" y="1828800"/>
-            <a:ext cx="2743200" cy="320040"/>
+            <a:ext cx="3108960" cy="320040"/>
           </a:xfrm>
           <a:prstGeom prst="rect">
             <a:avLst/>
@@ -3463,7 +3459,7 @@
                 <a:ea typeface="Cambria" pitchFamily="34" charset="-122"/>
                 <a:cs typeface="Cambria" pitchFamily="34" charset="-120"/>
               </a:rPr>
-              <a:t>Escenario actual</a:t>
+              <a:t>Reproducible en un comando</a:t>
             </a:r>
             <a:endParaRPr lang="en-US" sz="1400" dirty="0"/>
           </a:p>
@@ -3478,7 +3474,7 @@
         <p:spPr>
           <a:xfrm>
             <a:off x="640080" y="2194560"/>
-            <a:ext cx="2743200" cy="1005840"/>
+            <a:ext cx="3108960" cy="1097280"/>
           </a:xfrm>
           <a:prstGeom prst="rect">
             <a:avLst/>
@@ -3505,7 +3501,7 @@
                 <a:ea typeface="Calibri" pitchFamily="34" charset="-122"/>
                 <a:cs typeface="Calibri" pitchFamily="34" charset="-120"/>
               </a:rPr>
-              <a:t>Data Factory orquesta, Blob Storage almacena y Azure Functions ejecuta el pipeline desde una imagen Docker.</a:t>
+              <a:t>make all encadena ingesta, selección de modelo y pronóstico. Cada etapa corre también por separado con uv run.</a:t>
             </a:r>
             <a:endParaRPr lang="en-US" sz="1200" dirty="0"/>
           </a:p>
@@ -3519,8 +3515,8 @@
         </p:nvSpPr>
         <p:spPr>
           <a:xfrm>
-            <a:off x="640080" y="3383280"/>
-            <a:ext cx="2743200" cy="320040"/>
+            <a:off x="640080" y="3429000"/>
+            <a:ext cx="3108960" cy="320040"/>
           </a:xfrm>
           <a:prstGeom prst="rect">
             <a:avLst/>
@@ -3544,7 +3540,7 @@
                 <a:ea typeface="Cambria" pitchFamily="34" charset="-122"/>
                 <a:cs typeface="Cambria" pitchFamily="34" charset="-120"/>
               </a:rPr>
-              <a:t>Si crece</a:t>
+              <a:t>Artefactos versionados</a:t>
             </a:r>
             <a:endParaRPr lang="en-US" sz="1400" dirty="0"/>
           </a:p>
@@ -3558,8 +3554,8 @@
         </p:nvSpPr>
         <p:spPr>
           <a:xfrm>
-            <a:off x="640080" y="3749040"/>
-            <a:ext cx="2743200" cy="1005840"/>
+            <a:off x="640080" y="3794760"/>
+            <a:ext cx="3108960" cy="1280160"/>
           </a:xfrm>
           <a:prstGeom prst="rect">
             <a:avLst/>
@@ -3586,7 +3582,7 @@
                 <a:ea typeface="Calibri" pitchFamily="34" charset="-122"/>
                 <a:cs typeface="Calibri" pitchFamily="34" charset="-120"/>
               </a:rPr>
-              <a:t>ADLS Gen2 con Delta Lake y Databricks para volumen. Azure ML con MLflow si aparecen modelos costosos de entrenar.</a:t>
+              <a:t>El histórico procesado, la selección de modelo y los pronósticos quedan en el repositorio, de modo que el resultado es auditable sin reejecutar nada.</a:t>
             </a:r>
             <a:endParaRPr lang="en-US" sz="1200" dirty="0"/>
           </a:p>
@@ -3600,8 +3596,8 @@
         </p:nvSpPr>
         <p:spPr>
           <a:xfrm>
-            <a:off x="8869680" y="1828800"/>
-            <a:ext cx="2651760" cy="320040"/>
+            <a:off x="8412480" y="1828800"/>
+            <a:ext cx="3108960" cy="320040"/>
           </a:xfrm>
           <a:prstGeom prst="rect">
             <a:avLst/>
@@ -3625,7 +3621,7 @@
                 <a:ea typeface="Cambria" pitchFamily="34" charset="-122"/>
                 <a:cs typeface="Cambria" pitchFamily="34" charset="-120"/>
               </a:rPr>
-              <a:t>Consumo del agente</a:t>
+              <a:t>El agente</a:t>
             </a:r>
             <a:endParaRPr lang="en-US" sz="1400" dirty="0"/>
           </a:p>
@@ -3639,8 +3635,8 @@
         </p:nvSpPr>
         <p:spPr>
           <a:xfrm>
-            <a:off x="8869680" y="2194560"/>
-            <a:ext cx="2651760" cy="1097280"/>
+            <a:off x="8412480" y="2194560"/>
+            <a:ext cx="3108960" cy="1280160"/>
           </a:xfrm>
           <a:prstGeom prst="rect">
             <a:avLst/>
@@ -3667,7 +3663,7 @@
                 <a:ea typeface="Calibri" pitchFamily="34" charset="-122"/>
                 <a:cs typeface="Calibri" pitchFamily="34" charset="-120"/>
               </a:rPr>
-              <a:t>Como producto propio con Streamlit o FastAPI más Next.js, o embebido en un portal existente exponiendo solo la API.</a:t>
+              <a:t>El grafo decide si consulta la rama interna, que lee los artefactos, o la externa, que busca en la web, y mantiene el estado de la conversación.</a:t>
             </a:r>
             <a:endParaRPr lang="en-US" sz="1200" dirty="0"/>
           </a:p>
@@ -3681,8 +3677,8 @@
         </p:nvSpPr>
         <p:spPr>
           <a:xfrm>
-            <a:off x="8869680" y="3474720"/>
-            <a:ext cx="2651760" cy="320040"/>
+            <a:off x="8412480" y="3611880"/>
+            <a:ext cx="3108960" cy="320040"/>
           </a:xfrm>
           <a:prstGeom prst="rect">
             <a:avLst/>
@@ -3706,7 +3702,7 @@
                 <a:ea typeface="Cambria" pitchFamily="34" charset="-122"/>
                 <a:cs typeface="Cambria" pitchFamily="34" charset="-120"/>
               </a:rPr>
-              <a:t>Plataforma</a:t>
+              <a:t>Empaquetado</a:t>
             </a:r>
             <a:endParaRPr lang="en-US" sz="1400" dirty="0"/>
           </a:p>
@@ -3720,8 +3716,8 @@
         </p:nvSpPr>
         <p:spPr>
           <a:xfrm>
-            <a:off x="8869680" y="3840480"/>
-            <a:ext cx="2651760" cy="1097280"/>
+            <a:off x="8412480" y="3977640"/>
+            <a:ext cx="3108960" cy="1097280"/>
           </a:xfrm>
           <a:prstGeom prst="rect">
             <a:avLst/>
@@ -3748,7 +3744,7 @@
                 <a:ea typeface="Calibri" pitchFamily="34" charset="-122"/>
                 <a:cs typeface="Calibri" pitchFamily="34" charset="-120"/>
               </a:rPr>
-              <a:t>Postgres como checkpointer persistente, Key Vault para credenciales y Application Insights para observabilidad.</a:t>
+              <a:t>Un Dockerfile resuelve las dependencias de sistema y levanta el agente sin instalar nada en la máquina del usuario.</a:t>
             </a:r>
             <a:endParaRPr lang="en-US" sz="1200" dirty="0"/>
           </a:p>
@@ -3765,6 +3761,464 @@
 <file path=ppt/slides/slide12.xml><?xml version="1.0" encoding="utf-8"?>
 <p:sld xmlns:a="http://schemas.openxmlformats.org/drawingml/2006/main" xmlns:r="http://schemas.openxmlformats.org/officeDocument/2006/relationships" xmlns:p="http://schemas.openxmlformats.org/presentationml/2006/main">
   <p:cSld name="Slide 12">
+    <p:bg>
+      <p:bgPr>
+        <a:solidFill>
+          <a:srgbClr val="FFFFFF"/>
+        </a:solidFill>
+      </p:bgPr>
+    </p:bg>
+    <p:spTree>
+      <p:nvGrpSpPr>
+        <p:cNvPr id="1" name=""/>
+        <p:cNvGrpSpPr/>
+        <p:nvPr/>
+      </p:nvGrpSpPr>
+      <p:grpSpPr>
+        <a:xfrm>
+          <a:off x="0" y="0"/>
+          <a:ext cx="0" cy="0"/>
+          <a:chOff x="0" y="0"/>
+          <a:chExt cx="0" cy="0"/>
+        </a:xfrm>
+      </p:grpSpPr>
+      <p:sp>
+        <p:nvSpPr>
+          <p:cNvPr id="2" name="Text 0"/>
+          <p:cNvSpPr txBox="1"/>
+          <p:nvPr/>
+        </p:nvSpPr>
+        <p:spPr>
+          <a:xfrm>
+            <a:off x="640080" y="411480"/>
+            <a:ext cx="10881360" cy="594360"/>
+          </a:xfrm>
+          <a:prstGeom prst="rect">
+            <a:avLst/>
+          </a:prstGeom>
+          <a:noFill/>
+          <a:ln/>
+        </p:spPr>
+        <p:txBody>
+          <a:bodyPr wrap="square" lIns="0" tIns="0" rIns="0" bIns="0" rtlCol="0" anchor="ctr"/>
+          <a:lstStyle/>
+          <a:p>
+            <a:pPr indent="0" marL="0">
+              <a:buNone/>
+            </a:pPr>
+            <a:r>
+              <a:rPr lang="en-US" sz="3000" b="1" dirty="0">
+                <a:solidFill>
+                  <a:srgbClr val="2B2B28"/>
+                </a:solidFill>
+                <a:latin typeface="Cambria" pitchFamily="34" charset="0"/>
+                <a:ea typeface="Cambria" pitchFamily="34" charset="-122"/>
+                <a:cs typeface="Cambria" pitchFamily="34" charset="-120"/>
+              </a:rPr>
+              <a:t>Cómo escalaría en Azure</a:t>
+            </a:r>
+            <a:endParaRPr lang="en-US" sz="3000" dirty="0"/>
+          </a:p>
+        </p:txBody>
+      </p:sp>
+      <p:sp>
+        <p:nvSpPr>
+          <p:cNvPr id="3" name="Text 1"/>
+          <p:cNvSpPr txBox="1"/>
+          <p:nvPr/>
+        </p:nvSpPr>
+        <p:spPr>
+          <a:xfrm>
+            <a:off x="640080" y="1024128"/>
+            <a:ext cx="10881360" cy="365760"/>
+          </a:xfrm>
+          <a:prstGeom prst="rect">
+            <a:avLst/>
+          </a:prstGeom>
+          <a:noFill/>
+          <a:ln/>
+        </p:spPr>
+        <p:txBody>
+          <a:bodyPr wrap="square" lIns="0" tIns="0" rIns="0" bIns="0" rtlCol="0" anchor="ctr"/>
+          <a:lstStyle/>
+          <a:p>
+            <a:pPr indent="0" marL="0">
+              <a:buNone/>
+            </a:pPr>
+            <a:r>
+              <a:rPr lang="en-US" sz="1400" i="1" dirty="0">
+                <a:solidFill>
+                  <a:srgbClr val="6B6A64"/>
+                </a:solidFill>
+                <a:latin typeface="Calibri" pitchFamily="34" charset="0"/>
+                <a:ea typeface="Calibri" pitchFamily="34" charset="-122"/>
+                <a:cs typeface="Calibri" pitchFamily="34" charset="-120"/>
+              </a:rPr>
+              <a:t>La misma imagen que corre en local es la que se despliega, con dos configuraciones según el volumen</a:t>
+            </a:r>
+            <a:endParaRPr lang="en-US" sz="1400" dirty="0"/>
+          </a:p>
+        </p:txBody>
+      </p:sp>
+      <p:pic>
+        <p:nvPicPr>
+          <p:cNvPr id="4" name="Image 0" descr="docs/arquitectura_azure.png">    </p:cNvPr>
+          <p:cNvPicPr>
+            <a:picLocks noChangeAspect="1"/>
+          </p:cNvPicPr>
+          <p:nvPr/>
+        </p:nvPicPr>
+        <p:blipFill>
+          <a:blip r:embed="rId1"/>
+          <a:stretch>
+            <a:fillRect/>
+          </a:stretch>
+        </p:blipFill>
+        <p:spPr>
+          <a:xfrm>
+            <a:off x="3566160" y="1600200"/>
+            <a:ext cx="5029200" cy="4892040"/>
+          </a:xfrm>
+          <a:prstGeom prst="rect">
+            <a:avLst/>
+          </a:prstGeom>
+        </p:spPr>
+      </p:pic>
+      <p:sp>
+        <p:nvSpPr>
+          <p:cNvPr id="5" name="Text 2"/>
+          <p:cNvSpPr txBox="1"/>
+          <p:nvPr/>
+        </p:nvSpPr>
+        <p:spPr>
+          <a:xfrm>
+            <a:off x="640080" y="1828800"/>
+            <a:ext cx="2743200" cy="320040"/>
+          </a:xfrm>
+          <a:prstGeom prst="rect">
+            <a:avLst/>
+          </a:prstGeom>
+          <a:noFill/>
+          <a:ln/>
+        </p:spPr>
+        <p:txBody>
+          <a:bodyPr wrap="square" lIns="0" tIns="0" rIns="0" bIns="0" rtlCol="0" anchor="ctr"/>
+          <a:lstStyle/>
+          <a:p>
+            <a:pPr indent="0" marL="0">
+              <a:buNone/>
+            </a:pPr>
+            <a:r>
+              <a:rPr lang="en-US" sz="1400" b="1" dirty="0">
+                <a:solidFill>
+                  <a:srgbClr val="B85042"/>
+                </a:solidFill>
+                <a:latin typeface="Cambria" pitchFamily="34" charset="0"/>
+                <a:ea typeface="Cambria" pitchFamily="34" charset="-122"/>
+                <a:cs typeface="Cambria" pitchFamily="34" charset="-120"/>
+              </a:rPr>
+              <a:t>Escenario actual</a:t>
+            </a:r>
+            <a:endParaRPr lang="en-US" sz="1400" dirty="0"/>
+          </a:p>
+        </p:txBody>
+      </p:sp>
+      <p:sp>
+        <p:nvSpPr>
+          <p:cNvPr id="6" name="Text 3"/>
+          <p:cNvSpPr txBox="1"/>
+          <p:nvPr/>
+        </p:nvSpPr>
+        <p:spPr>
+          <a:xfrm>
+            <a:off x="640080" y="2194560"/>
+            <a:ext cx="2743200" cy="1005840"/>
+          </a:xfrm>
+          <a:prstGeom prst="rect">
+            <a:avLst/>
+          </a:prstGeom>
+          <a:noFill/>
+          <a:ln/>
+        </p:spPr>
+        <p:txBody>
+          <a:bodyPr wrap="square" lIns="0" tIns="0" rIns="0" bIns="0" rtlCol="0" anchor="ctr"/>
+          <a:lstStyle/>
+          <a:p>
+            <a:pPr indent="0" marL="0">
+              <a:lnSpc>
+                <a:spcPts val="1700"/>
+              </a:lnSpc>
+              <a:buNone/>
+            </a:pPr>
+            <a:r>
+              <a:rPr lang="en-US" sz="1200" dirty="0">
+                <a:solidFill>
+                  <a:srgbClr val="6B6A64"/>
+                </a:solidFill>
+                <a:latin typeface="Calibri" pitchFamily="34" charset="0"/>
+                <a:ea typeface="Calibri" pitchFamily="34" charset="-122"/>
+                <a:cs typeface="Calibri" pitchFamily="34" charset="-120"/>
+              </a:rPr>
+              <a:t>Data Factory orquesta, Blob Storage almacena y Azure Functions ejecuta el pipeline desde una imagen Docker.</a:t>
+            </a:r>
+            <a:endParaRPr lang="en-US" sz="1200" dirty="0"/>
+          </a:p>
+        </p:txBody>
+      </p:sp>
+      <p:sp>
+        <p:nvSpPr>
+          <p:cNvPr id="7" name="Text 4"/>
+          <p:cNvSpPr txBox="1"/>
+          <p:nvPr/>
+        </p:nvSpPr>
+        <p:spPr>
+          <a:xfrm>
+            <a:off x="640080" y="3383280"/>
+            <a:ext cx="2743200" cy="320040"/>
+          </a:xfrm>
+          <a:prstGeom prst="rect">
+            <a:avLst/>
+          </a:prstGeom>
+          <a:noFill/>
+          <a:ln/>
+        </p:spPr>
+        <p:txBody>
+          <a:bodyPr wrap="square" lIns="0" tIns="0" rIns="0" bIns="0" rtlCol="0" anchor="ctr"/>
+          <a:lstStyle/>
+          <a:p>
+            <a:pPr indent="0" marL="0">
+              <a:buNone/>
+            </a:pPr>
+            <a:r>
+              <a:rPr lang="en-US" sz="1400" b="1" dirty="0">
+                <a:solidFill>
+                  <a:srgbClr val="B85042"/>
+                </a:solidFill>
+                <a:latin typeface="Cambria" pitchFamily="34" charset="0"/>
+                <a:ea typeface="Cambria" pitchFamily="34" charset="-122"/>
+                <a:cs typeface="Cambria" pitchFamily="34" charset="-120"/>
+              </a:rPr>
+              <a:t>Si crece</a:t>
+            </a:r>
+            <a:endParaRPr lang="en-US" sz="1400" dirty="0"/>
+          </a:p>
+        </p:txBody>
+      </p:sp>
+      <p:sp>
+        <p:nvSpPr>
+          <p:cNvPr id="8" name="Text 5"/>
+          <p:cNvSpPr txBox="1"/>
+          <p:nvPr/>
+        </p:nvSpPr>
+        <p:spPr>
+          <a:xfrm>
+            <a:off x="640080" y="3749040"/>
+            <a:ext cx="2743200" cy="1005840"/>
+          </a:xfrm>
+          <a:prstGeom prst="rect">
+            <a:avLst/>
+          </a:prstGeom>
+          <a:noFill/>
+          <a:ln/>
+        </p:spPr>
+        <p:txBody>
+          <a:bodyPr wrap="square" lIns="0" tIns="0" rIns="0" bIns="0" rtlCol="0" anchor="ctr"/>
+          <a:lstStyle/>
+          <a:p>
+            <a:pPr indent="0" marL="0">
+              <a:lnSpc>
+                <a:spcPts val="1700"/>
+              </a:lnSpc>
+              <a:buNone/>
+            </a:pPr>
+            <a:r>
+              <a:rPr lang="en-US" sz="1200" dirty="0">
+                <a:solidFill>
+                  <a:srgbClr val="6B6A64"/>
+                </a:solidFill>
+                <a:latin typeface="Calibri" pitchFamily="34" charset="0"/>
+                <a:ea typeface="Calibri" pitchFamily="34" charset="-122"/>
+                <a:cs typeface="Calibri" pitchFamily="34" charset="-120"/>
+              </a:rPr>
+              <a:t>ADLS Gen2 con Delta Lake y Databricks para volumen. Azure ML con MLflow si aparecen modelos costosos de entrenar.</a:t>
+            </a:r>
+            <a:endParaRPr lang="en-US" sz="1200" dirty="0"/>
+          </a:p>
+        </p:txBody>
+      </p:sp>
+      <p:sp>
+        <p:nvSpPr>
+          <p:cNvPr id="9" name="Text 6"/>
+          <p:cNvSpPr txBox="1"/>
+          <p:nvPr/>
+        </p:nvSpPr>
+        <p:spPr>
+          <a:xfrm>
+            <a:off x="8869680" y="1828800"/>
+            <a:ext cx="2651760" cy="320040"/>
+          </a:xfrm>
+          <a:prstGeom prst="rect">
+            <a:avLst/>
+          </a:prstGeom>
+          <a:noFill/>
+          <a:ln/>
+        </p:spPr>
+        <p:txBody>
+          <a:bodyPr wrap="square" lIns="0" tIns="0" rIns="0" bIns="0" rtlCol="0" anchor="ctr"/>
+          <a:lstStyle/>
+          <a:p>
+            <a:pPr indent="0" marL="0">
+              <a:buNone/>
+            </a:pPr>
+            <a:r>
+              <a:rPr lang="en-US" sz="1400" b="1" dirty="0">
+                <a:solidFill>
+                  <a:srgbClr val="B85042"/>
+                </a:solidFill>
+                <a:latin typeface="Cambria" pitchFamily="34" charset="0"/>
+                <a:ea typeface="Cambria" pitchFamily="34" charset="-122"/>
+                <a:cs typeface="Cambria" pitchFamily="34" charset="-120"/>
+              </a:rPr>
+              <a:t>Consumo del agente</a:t>
+            </a:r>
+            <a:endParaRPr lang="en-US" sz="1400" dirty="0"/>
+          </a:p>
+        </p:txBody>
+      </p:sp>
+      <p:sp>
+        <p:nvSpPr>
+          <p:cNvPr id="10" name="Text 7"/>
+          <p:cNvSpPr txBox="1"/>
+          <p:nvPr/>
+        </p:nvSpPr>
+        <p:spPr>
+          <a:xfrm>
+            <a:off x="8869680" y="2194560"/>
+            <a:ext cx="2651760" cy="1097280"/>
+          </a:xfrm>
+          <a:prstGeom prst="rect">
+            <a:avLst/>
+          </a:prstGeom>
+          <a:noFill/>
+          <a:ln/>
+        </p:spPr>
+        <p:txBody>
+          <a:bodyPr wrap="square" lIns="0" tIns="0" rIns="0" bIns="0" rtlCol="0" anchor="ctr"/>
+          <a:lstStyle/>
+          <a:p>
+            <a:pPr indent="0" marL="0">
+              <a:lnSpc>
+                <a:spcPts val="1700"/>
+              </a:lnSpc>
+              <a:buNone/>
+            </a:pPr>
+            <a:r>
+              <a:rPr lang="en-US" sz="1200" dirty="0">
+                <a:solidFill>
+                  <a:srgbClr val="6B6A64"/>
+                </a:solidFill>
+                <a:latin typeface="Calibri" pitchFamily="34" charset="0"/>
+                <a:ea typeface="Calibri" pitchFamily="34" charset="-122"/>
+                <a:cs typeface="Calibri" pitchFamily="34" charset="-120"/>
+              </a:rPr>
+              <a:t>Como producto propio con Streamlit o FastAPI más Next.js, o embebido en un portal existente exponiendo solo la API.</a:t>
+            </a:r>
+            <a:endParaRPr lang="en-US" sz="1200" dirty="0"/>
+          </a:p>
+        </p:txBody>
+      </p:sp>
+      <p:sp>
+        <p:nvSpPr>
+          <p:cNvPr id="11" name="Text 8"/>
+          <p:cNvSpPr txBox="1"/>
+          <p:nvPr/>
+        </p:nvSpPr>
+        <p:spPr>
+          <a:xfrm>
+            <a:off x="8869680" y="3474720"/>
+            <a:ext cx="2651760" cy="320040"/>
+          </a:xfrm>
+          <a:prstGeom prst="rect">
+            <a:avLst/>
+          </a:prstGeom>
+          <a:noFill/>
+          <a:ln/>
+        </p:spPr>
+        <p:txBody>
+          <a:bodyPr wrap="square" lIns="0" tIns="0" rIns="0" bIns="0" rtlCol="0" anchor="ctr"/>
+          <a:lstStyle/>
+          <a:p>
+            <a:pPr indent="0" marL="0">
+              <a:buNone/>
+            </a:pPr>
+            <a:r>
+              <a:rPr lang="en-US" sz="1400" b="1" dirty="0">
+                <a:solidFill>
+                  <a:srgbClr val="B85042"/>
+                </a:solidFill>
+                <a:latin typeface="Cambria" pitchFamily="34" charset="0"/>
+                <a:ea typeface="Cambria" pitchFamily="34" charset="-122"/>
+                <a:cs typeface="Cambria" pitchFamily="34" charset="-120"/>
+              </a:rPr>
+              <a:t>Plataforma</a:t>
+            </a:r>
+            <a:endParaRPr lang="en-US" sz="1400" dirty="0"/>
+          </a:p>
+        </p:txBody>
+      </p:sp>
+      <p:sp>
+        <p:nvSpPr>
+          <p:cNvPr id="12" name="Text 9"/>
+          <p:cNvSpPr txBox="1"/>
+          <p:nvPr/>
+        </p:nvSpPr>
+        <p:spPr>
+          <a:xfrm>
+            <a:off x="8869680" y="3840480"/>
+            <a:ext cx="2651760" cy="1097280"/>
+          </a:xfrm>
+          <a:prstGeom prst="rect">
+            <a:avLst/>
+          </a:prstGeom>
+          <a:noFill/>
+          <a:ln/>
+        </p:spPr>
+        <p:txBody>
+          <a:bodyPr wrap="square" lIns="0" tIns="0" rIns="0" bIns="0" rtlCol="0" anchor="ctr"/>
+          <a:lstStyle/>
+          <a:p>
+            <a:pPr indent="0" marL="0">
+              <a:lnSpc>
+                <a:spcPts val="1700"/>
+              </a:lnSpc>
+              <a:buNone/>
+            </a:pPr>
+            <a:r>
+              <a:rPr lang="en-US" sz="1200" dirty="0">
+                <a:solidFill>
+                  <a:srgbClr val="6B6A64"/>
+                </a:solidFill>
+                <a:latin typeface="Calibri" pitchFamily="34" charset="0"/>
+                <a:ea typeface="Calibri" pitchFamily="34" charset="-122"/>
+                <a:cs typeface="Calibri" pitchFamily="34" charset="-120"/>
+              </a:rPr>
+              <a:t>Postgres como checkpointer persistente, Key Vault para credenciales y Application Insights para observabilidad.</a:t>
+            </a:r>
+            <a:endParaRPr lang="en-US" sz="1200" dirty="0"/>
+          </a:p>
+        </p:txBody>
+      </p:sp>
+    </p:spTree>
+  </p:cSld>
+  <p:clrMapOvr>
+    <a:masterClrMapping/>
+  </p:clrMapOvr>
+</p:sld>
+</file>
+
+<file path=ppt/slides/slide13.xml><?xml version="1.0" encoding="utf-8"?>
+<p:sld xmlns:a="http://schemas.openxmlformats.org/drawingml/2006/main" xmlns:r="http://schemas.openxmlformats.org/officeDocument/2006/relationships" xmlns:p="http://schemas.openxmlformats.org/presentationml/2006/main">
+  <p:cSld name="Slide 13">
     <p:bg>
       <p:bgPr>
         <a:solidFill>

</xml_diff>